<commit_message>
Expand alternative TA deck explanations
</commit_message>
<xml_diff>
--- a/Pitchdeck_TA_Supervisory_Agent_Alternatif.pptx
+++ b/Pitchdeck_TA_Supervisory_Agent_Alternatif.pptx
@@ -3996,7 +3996,7 @@
         <p:spPr>
           <a:xfrm>
             <a:off x="658368" y="2752344"/>
-            <a:ext cx="3346704" cy="2231136"/>
+            <a:ext cx="3346704" cy="2441448"/>
           </a:xfrm>
           <a:prstGeom prst="roundRect">
             <a:avLst>
@@ -4155,22 +4155,22 @@
         </p:nvSpPr>
         <p:spPr>
           <a:xfrm>
-            <a:off x="841247" y="4050791"/>
-            <a:ext cx="2889504" cy="640080"/>
-          </a:xfrm>
-          <a:prstGeom prst="rect">
-            <a:avLst/>
-          </a:prstGeom>
-          <a:noFill/>
-        </p:spPr>
-        <p:txBody>
-          <a:bodyPr wrap="square" lIns="9144" rIns="9144" tIns="9144" bIns="9144">
-            <a:spAutoFit/>
-          </a:bodyPr>
-          <a:lstStyle/>
-          <a:p>
-            <a:pPr>
-              <a:defRPr sz="1500" b="0">
+            <a:off x="841247" y="3995928"/>
+            <a:ext cx="2889504" cy="932688"/>
+          </a:xfrm>
+          <a:prstGeom prst="rect">
+            <a:avLst/>
+          </a:prstGeom>
+          <a:noFill/>
+        </p:spPr>
+        <p:txBody>
+          <a:bodyPr wrap="square" lIns="9144" rIns="9144" tIns="9144" bIns="9144">
+            <a:spAutoFit/>
+          </a:bodyPr>
+          <a:lstStyle/>
+          <a:p>
+            <a:pPr>
+              <a:defRPr sz="1400" b="0">
                 <a:solidFill>
                   <a:srgbClr val="5C6B6F"/>
                 </a:solidFill>
@@ -4178,7 +4178,7 @@
               </a:defRPr>
             </a:pPr>
             <a:r>
-              <a:t>Sinyal asal melemah; trafik terputus.</a:t>
+              <a:t>UE masih terhubung ke sel A ketika sinyalnya sudah lemah. Video/data dapat terhenti.</a:t>
             </a:r>
           </a:p>
         </p:txBody>
@@ -4192,7 +4192,7 @@
         <p:spPr>
           <a:xfrm>
             <a:off x="4416552" y="2752344"/>
-            <a:ext cx="3346704" cy="2231136"/>
+            <a:ext cx="3346704" cy="2441448"/>
           </a:xfrm>
           <a:prstGeom prst="roundRect">
             <a:avLst>
@@ -4351,22 +4351,22 @@
         </p:nvSpPr>
         <p:spPr>
           <a:xfrm>
-            <a:off x="4599432" y="4050791"/>
-            <a:ext cx="2889504" cy="640080"/>
-          </a:xfrm>
-          <a:prstGeom prst="rect">
-            <a:avLst/>
-          </a:prstGeom>
-          <a:noFill/>
-        </p:spPr>
-        <p:txBody>
-          <a:bodyPr wrap="square" lIns="9144" rIns="9144" tIns="9144" bIns="9144">
-            <a:spAutoFit/>
-          </a:bodyPr>
-          <a:lstStyle/>
-          <a:p>
-            <a:pPr>
-              <a:defRPr sz="1500" b="0">
+            <a:off x="4599432" y="3995928"/>
+            <a:ext cx="2889504" cy="932688"/>
+          </a:xfrm>
+          <a:prstGeom prst="rect">
+            <a:avLst/>
+          </a:prstGeom>
+          <a:noFill/>
+        </p:spPr>
+        <p:txBody>
+          <a:bodyPr wrap="square" lIns="9144" rIns="9144" tIns="9144" bIns="9144">
+            <a:spAutoFit/>
+          </a:bodyPr>
+          <a:lstStyle/>
+          <a:p>
+            <a:pPr>
+              <a:defRPr sz="1400" b="0">
                 <a:solidFill>
                   <a:srgbClr val="5C6B6F"/>
                 </a:solidFill>
@@ -4374,7 +4374,7 @@
               </a:defRPr>
             </a:pPr>
             <a:r>
-              <a:t>UE bolak-balik: ping-pong A–B–A.</a:t>
+              <a:t>UE berpindah A–B–A dalam waktu singkat (ping-pong); proses kontrol berulang.</a:t>
             </a:r>
           </a:p>
         </p:txBody>
@@ -4388,7 +4388,7 @@
         <p:spPr>
           <a:xfrm>
             <a:off x="8174736" y="2752344"/>
-            <a:ext cx="3346704" cy="2231136"/>
+            <a:ext cx="3346704" cy="2441448"/>
           </a:xfrm>
           <a:prstGeom prst="roundRect">
             <a:avLst>
@@ -4547,22 +4547,22 @@
         </p:nvSpPr>
         <p:spPr>
           <a:xfrm>
-            <a:off x="8357615" y="4050791"/>
-            <a:ext cx="2889504" cy="640080"/>
-          </a:xfrm>
-          <a:prstGeom prst="rect">
-            <a:avLst/>
-          </a:prstGeom>
-          <a:noFill/>
-        </p:spPr>
-        <p:txBody>
-          <a:bodyPr wrap="square" lIns="9144" rIns="9144" tIns="9144" bIns="9144">
-            <a:spAutoFit/>
-          </a:bodyPr>
-          <a:lstStyle/>
-          <a:p>
-            <a:pPr>
-              <a:defRPr sz="1500" b="0">
+            <a:off x="8357615" y="3995928"/>
+            <a:ext cx="2889504" cy="932688"/>
+          </a:xfrm>
+          <a:prstGeom prst="rect">
+            <a:avLst/>
+          </a:prstGeom>
+          <a:noFill/>
+        </p:spPr>
+        <p:txBody>
+          <a:bodyPr wrap="square" lIns="9144" rIns="9144" tIns="9144" bIns="9144">
+            <a:spAutoFit/>
+          </a:bodyPr>
+          <a:lstStyle/>
+          <a:p>
+            <a:pPr>
+              <a:defRPr sz="1400" b="0">
                 <a:solidFill>
                   <a:srgbClr val="5C6B6F"/>
                 </a:solidFill>
@@ -4570,7 +4570,7 @@
               </a:defRPr>
             </a:pPr>
             <a:r>
-              <a:t>Layanan tetap stabil saat berpindah.</a:t>
+              <a:t>UE pindah ketika sel B cukup baik, sehingga trafik cepat pulih dan koneksi stabil.</a:t>
             </a:r>
           </a:p>
         </p:txBody>
@@ -4583,7 +4583,7 @@
         </p:nvSpPr>
         <p:spPr>
           <a:xfrm>
-            <a:off x="658368" y="5705856"/>
+            <a:off x="658368" y="5376672"/>
             <a:ext cx="10881360" cy="310896"/>
           </a:xfrm>
           <a:prstGeom prst="rect">
@@ -4598,6 +4598,42 @@
           <a:lstStyle/>
           <a:p>
             <a:pPr>
+              <a:defRPr sz="1500" b="1">
+                <a:solidFill>
+                  <a:srgbClr val="007A80"/>
+                </a:solidFill>
+                <a:latin typeface="Aptos Display"/>
+              </a:defRPr>
+            </a:pPr>
+            <a:r>
+              <a:t>Handover = pemindahan koneksi UE (perangkat pengguna) antar-sel saat bergerak.</a:t>
+            </a:r>
+          </a:p>
+        </p:txBody>
+      </p:sp>
+      <p:sp>
+        <p:nvSpPr>
+          <p:cNvPr id="31" name="TextBox 30"/>
+          <p:cNvSpPr txBox="1"/>
+          <p:nvPr/>
+        </p:nvSpPr>
+        <p:spPr>
+          <a:xfrm>
+            <a:off x="658368" y="5815584"/>
+            <a:ext cx="10881360" cy="347472"/>
+          </a:xfrm>
+          <a:prstGeom prst="rect">
+            <a:avLst/>
+          </a:prstGeom>
+          <a:noFill/>
+        </p:spPr>
+        <p:txBody>
+          <a:bodyPr wrap="square" lIns="9144" rIns="9144" tIns="9144" bIns="9144">
+            <a:spAutoFit/>
+          </a:bodyPr>
+          <a:lstStyle/>
+          <a:p>
+            <a:pPr>
               <a:defRPr sz="1700" b="1">
                 <a:solidFill>
                   <a:srgbClr val="111F2B"/>
@@ -4606,7 +4642,7 @@
               </a:defRPr>
             </a:pPr>
             <a:r>
-              <a:t>Pertanyaan penelitian: bagaimana menjaga lebih banyak handover berada pada skenario ketiga?</a:t>
+              <a:t>Pertanyaan penelitian: bagaimana mengurangi dua skenario buruk tanpa menambah kegagalan pindah sel?</a:t>
             </a:r>
           </a:p>
         </p:txBody>
@@ -5259,7 +5295,7 @@
           <a:lstStyle/>
           <a:p>
             <a:pPr>
-              <a:defRPr sz="2100" b="1">
+              <a:defRPr sz="1800" b="1">
                 <a:solidFill>
                   <a:srgbClr val="FFFFFF"/>
                 </a:solidFill>
@@ -5267,20 +5303,92 @@
               </a:defRPr>
             </a:pPr>
             <a:r>
-              <a:t>Berapa lama keunggulan bertahan?</a:t>
-            </a:r>
-          </a:p>
-        </p:txBody>
-      </p:sp>
-      <p:sp>
-        <p:nvSpPr>
-          <p:cNvPr id="18" name="Rounded Rectangle 17"/>
+              <a:t>Berapa lama sinyal harus lebih baik?</a:t>
+            </a:r>
+          </a:p>
+        </p:txBody>
+      </p:sp>
+      <p:sp>
+        <p:nvSpPr>
+          <p:cNvPr id="18" name="TextBox 17"/>
+          <p:cNvSpPr txBox="1"/>
+          <p:nvPr/>
+        </p:nvSpPr>
+        <p:spPr>
+          <a:xfrm>
+            <a:off x="640080" y="3657600"/>
+            <a:ext cx="5065776" cy="585216"/>
+          </a:xfrm>
+          <a:prstGeom prst="rect">
+            <a:avLst/>
+          </a:prstGeom>
+          <a:noFill/>
+        </p:spPr>
+        <p:txBody>
+          <a:bodyPr wrap="square" lIns="9144" rIns="9144" tIns="9144" bIns="9144">
+            <a:spAutoFit/>
+          </a:bodyPr>
+          <a:lstStyle/>
+          <a:p>
+            <a:pPr>
+              <a:defRPr sz="1400" b="0">
+                <a:solidFill>
+                  <a:srgbClr val="C2ECDC"/>
+                </a:solidFill>
+                <a:latin typeface="Aptos"/>
+              </a:defRPr>
+            </a:pPr>
+            <a:r>
+              <a:t>Event A3 membandingkan kualitas sinyal sel asal dan tetangga. Offset menentukan ambang selisihnya.</a:t>
+            </a:r>
+          </a:p>
+        </p:txBody>
+      </p:sp>
+      <p:sp>
+        <p:nvSpPr>
+          <p:cNvPr id="19" name="TextBox 18"/>
+          <p:cNvSpPr txBox="1"/>
+          <p:nvPr/>
+        </p:nvSpPr>
+        <p:spPr>
+          <a:xfrm>
+            <a:off x="6492240" y="3657600"/>
+            <a:ext cx="5065776" cy="585216"/>
+          </a:xfrm>
+          <a:prstGeom prst="rect">
+            <a:avLst/>
+          </a:prstGeom>
+          <a:noFill/>
+        </p:spPr>
+        <p:txBody>
+          <a:bodyPr wrap="square" lIns="9144" rIns="9144" tIns="9144" bIns="9144">
+            <a:spAutoFit/>
+          </a:bodyPr>
+          <a:lstStyle/>
+          <a:p>
+            <a:pPr>
+              <a:defRPr sz="1400" b="0">
+                <a:solidFill>
+                  <a:srgbClr val="C2ECDC"/>
+                </a:solidFill>
+                <a:latin typeface="Aptos"/>
+              </a:defRPr>
+            </a:pPr>
+            <a:r>
+              <a:t>TTT (time-to-trigger) menahan keputusan hingga selisih sinyal bertahan selama durasi tertentu.</a:t>
+            </a:r>
+          </a:p>
+        </p:txBody>
+      </p:sp>
+      <p:sp>
+        <p:nvSpPr>
+          <p:cNvPr id="20" name="Rounded Rectangle 19"/>
           <p:cNvSpPr/>
           <p:nvPr/>
         </p:nvSpPr>
         <p:spPr>
           <a:xfrm>
-            <a:off x="640080" y="4270248"/>
+            <a:off x="640080" y="4645152"/>
             <a:ext cx="10808208" cy="1207008"/>
           </a:xfrm>
           <a:prstGeom prst="roundRect">
@@ -5319,13 +5427,13 @@
       </p:sp>
       <p:sp>
         <p:nvSpPr>
-          <p:cNvPr id="19" name="TextBox 18"/>
-          <p:cNvSpPr txBox="1"/>
-          <p:nvPr/>
-        </p:nvSpPr>
-        <p:spPr>
-          <a:xfrm>
-            <a:off x="914400" y="4517136"/>
+          <p:cNvPr id="21" name="TextBox 20"/>
+          <p:cNvSpPr txBox="1"/>
+          <p:nvPr/>
+        </p:nvSpPr>
+        <p:spPr>
+          <a:xfrm>
+            <a:off x="914400" y="4864608"/>
             <a:ext cx="2194560" cy="320040"/>
           </a:xfrm>
           <a:prstGeom prst="rect">
@@ -5355,13 +5463,13 @@
       </p:sp>
       <p:sp>
         <p:nvSpPr>
-          <p:cNvPr id="20" name="TextBox 19"/>
-          <p:cNvSpPr txBox="1"/>
-          <p:nvPr/>
-        </p:nvSpPr>
-        <p:spPr>
-          <a:xfrm>
-            <a:off x="914400" y="4928616"/>
+          <p:cNvPr id="22" name="TextBox 21"/>
+          <p:cNvSpPr txBox="1"/>
+          <p:nvPr/>
+        </p:nvSpPr>
+        <p:spPr>
+          <a:xfrm>
+            <a:off x="914400" y="5276088"/>
             <a:ext cx="4480560" cy="292608"/>
           </a:xfrm>
           <a:prstGeom prst="rect">
@@ -5391,13 +5499,13 @@
       </p:sp>
       <p:sp>
         <p:nvSpPr>
-          <p:cNvPr id="21" name="TextBox 20"/>
-          <p:cNvSpPr txBox="1"/>
-          <p:nvPr/>
-        </p:nvSpPr>
-        <p:spPr>
-          <a:xfrm>
-            <a:off x="6144768" y="4517136"/>
+          <p:cNvPr id="23" name="TextBox 22"/>
+          <p:cNvSpPr txBox="1"/>
+          <p:nvPr/>
+        </p:nvSpPr>
+        <p:spPr>
+          <a:xfrm>
+            <a:off x="6144768" y="4864608"/>
             <a:ext cx="3291840" cy="320040"/>
           </a:xfrm>
           <a:prstGeom prst="rect">
@@ -5427,13 +5535,13 @@
       </p:sp>
       <p:sp>
         <p:nvSpPr>
-          <p:cNvPr id="22" name="TextBox 21"/>
-          <p:cNvSpPr txBox="1"/>
-          <p:nvPr/>
-        </p:nvSpPr>
-        <p:spPr>
-          <a:xfrm>
-            <a:off x="6144768" y="4928616"/>
+          <p:cNvPr id="24" name="TextBox 23"/>
+          <p:cNvSpPr txBox="1"/>
+          <p:nvPr/>
+        </p:nvSpPr>
+        <p:spPr>
+          <a:xfrm>
+            <a:off x="6144768" y="5276088"/>
             <a:ext cx="4754880" cy="292608"/>
           </a:xfrm>
           <a:prstGeom prst="rect">
@@ -5887,21 +5995,21 @@
         <p:spPr>
           <a:xfrm>
             <a:off x="941832" y="3685032"/>
-            <a:ext cx="2249424" cy="512064"/>
-          </a:xfrm>
-          <a:prstGeom prst="rect">
-            <a:avLst/>
-          </a:prstGeom>
-          <a:noFill/>
-        </p:spPr>
-        <p:txBody>
-          <a:bodyPr wrap="square" lIns="9144" rIns="9144" tIns="9144" bIns="9144">
-            <a:spAutoFit/>
-          </a:bodyPr>
-          <a:lstStyle/>
-          <a:p>
-            <a:pPr>
-              <a:defRPr sz="1500" b="0">
+            <a:ext cx="2249424" cy="813816"/>
+          </a:xfrm>
+          <a:prstGeom prst="rect">
+            <a:avLst/>
+          </a:prstGeom>
+          <a:noFill/>
+        </p:spPr>
+        <p:txBody>
+          <a:bodyPr wrap="square" lIns="9144" rIns="9144" tIns="9144" bIns="9144">
+            <a:spAutoFit/>
+          </a:bodyPr>
+          <a:lstStyle/>
+          <a:p>
+            <a:pPr>
+              <a:defRPr sz="1400" b="0">
                 <a:solidFill>
                   <a:srgbClr val="5C6B6F"/>
                 </a:solidFill>
@@ -5909,7 +6017,7 @@
               </a:defRPr>
             </a:pPr>
             <a:r>
-              <a:t>Ringkas telemetri</a:t>
+              <a:t>Telemetri: log sinyal, handover, dan trafik</a:t>
             </a:r>
           </a:p>
         </p:txBody>
@@ -6040,21 +6148,21 @@
         <p:spPr>
           <a:xfrm>
             <a:off x="3749039" y="3685032"/>
-            <a:ext cx="2249424" cy="512064"/>
-          </a:xfrm>
-          <a:prstGeom prst="rect">
-            <a:avLst/>
-          </a:prstGeom>
-          <a:noFill/>
-        </p:spPr>
-        <p:txBody>
-          <a:bodyPr wrap="square" lIns="9144" rIns="9144" tIns="9144" bIns="9144">
-            <a:spAutoFit/>
-          </a:bodyPr>
-          <a:lstStyle/>
-          <a:p>
-            <a:pPr>
-              <a:defRPr sz="1500" b="0">
+            <a:ext cx="2249424" cy="813816"/>
+          </a:xfrm>
+          <a:prstGeom prst="rect">
+            <a:avLst/>
+          </a:prstGeom>
+          <a:noFill/>
+        </p:spPr>
+        <p:txBody>
+          <a:bodyPr wrap="square" lIns="9144" rIns="9144" tIns="9144" bIns="9144">
+            <a:spAutoFit/>
+          </a:bodyPr>
+          <a:lstStyle/>
+          <a:p>
+            <a:pPr>
+              <a:defRPr sz="1400" b="0">
                 <a:solidFill>
                   <a:srgbClr val="5C6B6F"/>
                 </a:solidFill>
@@ -6062,7 +6170,7 @@
               </a:defRPr>
             </a:pPr>
             <a:r>
-              <a:t>Pilih offset / TTT</a:t>
+              <a:t>Agen memilih offset / TTT dari opsi terbatas</a:t>
             </a:r>
           </a:p>
         </p:txBody>
@@ -6193,21 +6301,21 @@
         <p:spPr>
           <a:xfrm>
             <a:off x="6556248" y="3685032"/>
-            <a:ext cx="2249424" cy="512064"/>
-          </a:xfrm>
-          <a:prstGeom prst="rect">
-            <a:avLst/>
-          </a:prstGeom>
-          <a:noFill/>
-        </p:spPr>
-        <p:txBody>
-          <a:bodyPr wrap="square" lIns="9144" rIns="9144" tIns="9144" bIns="9144">
-            <a:spAutoFit/>
-          </a:bodyPr>
-          <a:lstStyle/>
-          <a:p>
-            <a:pPr>
-              <a:defRPr sz="1500" b="0">
+            <a:ext cx="2249424" cy="813816"/>
+          </a:xfrm>
+          <a:prstGeom prst="rect">
+            <a:avLst/>
+          </a:prstGeom>
+          <a:noFill/>
+        </p:spPr>
+        <p:txBody>
+          <a:bodyPr wrap="square" lIns="9144" rIns="9144" tIns="9144" bIns="9144">
+            <a:spAutoFit/>
+          </a:bodyPr>
+          <a:lstStyle/>
+          <a:p>
+            <a:pPr>
+              <a:defRPr sz="1400" b="0">
                 <a:solidFill>
                   <a:srgbClr val="5C6B6F"/>
                 </a:solidFill>
@@ -6215,7 +6323,7 @@
               </a:defRPr>
             </a:pPr>
             <a:r>
-              <a:t>Cek batas aman</a:t>
+              <a:t>Aturan deterministik menolak nilai tidak aman</a:t>
             </a:r>
           </a:p>
         </p:txBody>
@@ -6346,21 +6454,21 @@
         <p:spPr>
           <a:xfrm>
             <a:off x="9180576" y="3685032"/>
-            <a:ext cx="2249424" cy="512064"/>
-          </a:xfrm>
-          <a:prstGeom prst="rect">
-            <a:avLst/>
-          </a:prstGeom>
-          <a:noFill/>
-        </p:spPr>
-        <p:txBody>
-          <a:bodyPr wrap="square" lIns="9144" rIns="9144" tIns="9144" bIns="9144">
-            <a:spAutoFit/>
-          </a:bodyPr>
-          <a:lstStyle/>
-          <a:p>
-            <a:pPr>
-              <a:defRPr sz="1500" b="0">
+            <a:ext cx="2249424" cy="813816"/>
+          </a:xfrm>
+          <a:prstGeom prst="rect">
+            <a:avLst/>
+          </a:prstGeom>
+          <a:noFill/>
+        </p:spPr>
+        <p:txBody>
+          <a:bodyPr wrap="square" lIns="9144" rIns="9144" tIns="9144" bIns="9144">
+            <a:spAutoFit/>
+          </a:bodyPr>
+          <a:lstStyle/>
+          <a:p>
+            <a:pPr>
+              <a:defRPr sz="1400" b="0">
                 <a:solidFill>
                   <a:srgbClr val="5C6B6F"/>
                 </a:solidFill>
@@ -6368,7 +6476,7 @@
               </a:defRPr>
             </a:pPr>
             <a:r>
-              <a:t>Ukur dan rollback</a:t>
+              <a:t>Ukur hasil; rollback jika kinerja memburuk</a:t>
             </a:r>
           </a:p>
         </p:txBody>
@@ -6489,22 +6597,22 @@
         </p:nvSpPr>
         <p:spPr>
           <a:xfrm>
-            <a:off x="704088" y="5321808"/>
-            <a:ext cx="10698480" cy="438912"/>
-          </a:xfrm>
-          <a:prstGeom prst="rect">
-            <a:avLst/>
-          </a:prstGeom>
-          <a:noFill/>
-        </p:spPr>
-        <p:txBody>
-          <a:bodyPr wrap="square" lIns="9144" rIns="9144" tIns="9144" bIns="9144">
-            <a:spAutoFit/>
-          </a:bodyPr>
-          <a:lstStyle/>
-          <a:p>
-            <a:pPr>
-              <a:defRPr sz="2100" b="1">
+            <a:off x="704088" y="5248656"/>
+            <a:ext cx="10698480" cy="749808"/>
+          </a:xfrm>
+          <a:prstGeom prst="rect">
+            <a:avLst/>
+          </a:prstGeom>
+          <a:noFill/>
+        </p:spPr>
+        <p:txBody>
+          <a:bodyPr wrap="square" lIns="9144" rIns="9144" tIns="9144" bIns="9144">
+            <a:spAutoFit/>
+          </a:bodyPr>
+          <a:lstStyle/>
+          <a:p>
+            <a:pPr>
+              <a:defRPr sz="1900" b="1">
                 <a:solidFill>
                   <a:srgbClr val="111F2B"/>
                 </a:solidFill>
@@ -6512,7 +6620,7 @@
               </a:defRPr>
             </a:pPr>
             <a:r>
-              <a:t>Agen beroperasi pada loop pengawasan, bukan pada setiap kejadian handover.</a:t>
+              <a:t>Supervisory berarti agen meninjau tren secara berkala; keputusan handover langsung tetap dijalankan oleh RAN.</a:t>
             </a:r>
           </a:p>
         </p:txBody>
@@ -6781,7 +6889,7 @@
         <p:spPr>
           <a:xfrm>
             <a:off x="621792" y="2167128"/>
-            <a:ext cx="2395728" cy="2350008"/>
+            <a:ext cx="2395728" cy="2450592"/>
           </a:xfrm>
           <a:prstGeom prst="roundRect">
             <a:avLst>
@@ -6868,7 +6976,7 @@
         </p:nvSpPr>
         <p:spPr>
           <a:xfrm>
-            <a:off x="786384" y="2487168"/>
+            <a:off x="786384" y="2395728"/>
             <a:ext cx="2057400" cy="274320"/>
           </a:xfrm>
           <a:prstGeom prst="rect">
@@ -6904,22 +7012,22 @@
         </p:nvSpPr>
         <p:spPr>
           <a:xfrm>
-            <a:off x="786384" y="3182112"/>
-            <a:ext cx="2066543" cy="758952"/>
-          </a:xfrm>
-          <a:prstGeom prst="rect">
-            <a:avLst/>
-          </a:prstGeom>
-          <a:noFill/>
-        </p:spPr>
-        <p:txBody>
-          <a:bodyPr wrap="square" lIns="9144" rIns="9144" tIns="9144" bIns="9144">
-            <a:spAutoFit/>
-          </a:bodyPr>
-          <a:lstStyle/>
-          <a:p>
-            <a:pPr>
-              <a:defRPr sz="2000" b="1">
+            <a:off x="786384" y="2935224"/>
+            <a:ext cx="2066543" cy="594360"/>
+          </a:xfrm>
+          <a:prstGeom prst="rect">
+            <a:avLst/>
+          </a:prstGeom>
+          <a:noFill/>
+        </p:spPr>
+        <p:txBody>
+          <a:bodyPr wrap="square" lIns="9144" rIns="9144" tIns="9144" bIns="9144">
+            <a:spAutoFit/>
+          </a:bodyPr>
+          <a:lstStyle/>
+          <a:p>
+            <a:pPr>
+              <a:defRPr sz="1900" b="1">
                 <a:solidFill>
                   <a:srgbClr val="FFFFFF"/>
                 </a:solidFill>
@@ -6934,14 +7042,50 @@
       </p:sp>
       <p:sp>
         <p:nvSpPr>
-          <p:cNvPr id="12" name="Rounded Rectangle 11"/>
+          <p:cNvPr id="12" name="TextBox 11"/>
+          <p:cNvSpPr txBox="1"/>
+          <p:nvPr/>
+        </p:nvSpPr>
+        <p:spPr>
+          <a:xfrm>
+            <a:off x="786384" y="3666744"/>
+            <a:ext cx="2057400" cy="713232"/>
+          </a:xfrm>
+          <a:prstGeom prst="rect">
+            <a:avLst/>
+          </a:prstGeom>
+          <a:noFill/>
+        </p:spPr>
+        <p:txBody>
+          <a:bodyPr wrap="square" lIns="9144" rIns="9144" tIns="9144" bIns="9144">
+            <a:spAutoFit/>
+          </a:bodyPr>
+          <a:lstStyle/>
+          <a:p>
+            <a:pPr>
+              <a:defRPr sz="1300" b="0">
+                <a:solidFill>
+                  <a:srgbClr val="C2ECDC"/>
+                </a:solidFill>
+                <a:latin typeface="Aptos"/>
+              </a:defRPr>
+            </a:pPr>
+            <a:r>
+              <a:t>Mengelola sesi dan koneksi data UE</a:t>
+            </a:r>
+          </a:p>
+        </p:txBody>
+      </p:sp>
+      <p:sp>
+        <p:nvSpPr>
+          <p:cNvPr id="13" name="Rounded Rectangle 12"/>
           <p:cNvSpPr/>
           <p:nvPr/>
         </p:nvSpPr>
         <p:spPr>
           <a:xfrm>
             <a:off x="3474720" y="2167128"/>
-            <a:ext cx="2395728" cy="2350008"/>
+            <a:ext cx="2395728" cy="2450592"/>
           </a:xfrm>
           <a:prstGeom prst="roundRect">
             <a:avLst>
@@ -6979,7 +7123,7 @@
       </p:sp>
       <p:sp>
         <p:nvSpPr>
-          <p:cNvPr id="13" name="Rectangle 12"/>
+          <p:cNvPr id="14" name="Rectangle 13"/>
           <p:cNvSpPr/>
           <p:nvPr/>
         </p:nvSpPr>
@@ -7022,13 +7166,13 @@
       </p:sp>
       <p:sp>
         <p:nvSpPr>
-          <p:cNvPr id="14" name="TextBox 13"/>
-          <p:cNvSpPr txBox="1"/>
-          <p:nvPr/>
-        </p:nvSpPr>
-        <p:spPr>
-          <a:xfrm>
-            <a:off x="3639312" y="2487168"/>
+          <p:cNvPr id="15" name="TextBox 14"/>
+          <p:cNvSpPr txBox="1"/>
+          <p:nvPr/>
+        </p:nvSpPr>
+        <p:spPr>
+          <a:xfrm>
+            <a:off x="3639312" y="2395728"/>
             <a:ext cx="2057400" cy="274320"/>
           </a:xfrm>
           <a:prstGeom prst="rect">
@@ -7058,28 +7202,28 @@
       </p:sp>
       <p:sp>
         <p:nvSpPr>
-          <p:cNvPr id="15" name="TextBox 14"/>
-          <p:cNvSpPr txBox="1"/>
-          <p:nvPr/>
-        </p:nvSpPr>
-        <p:spPr>
-          <a:xfrm>
-            <a:off x="3639312" y="3182112"/>
-            <a:ext cx="2066543" cy="758952"/>
-          </a:xfrm>
-          <a:prstGeom prst="rect">
-            <a:avLst/>
-          </a:prstGeom>
-          <a:noFill/>
-        </p:spPr>
-        <p:txBody>
-          <a:bodyPr wrap="square" lIns="9144" rIns="9144" tIns="9144" bIns="9144">
-            <a:spAutoFit/>
-          </a:bodyPr>
-          <a:lstStyle/>
-          <a:p>
-            <a:pPr>
-              <a:defRPr sz="2000" b="1">
+          <p:cNvPr id="16" name="TextBox 15"/>
+          <p:cNvSpPr txBox="1"/>
+          <p:nvPr/>
+        </p:nvSpPr>
+        <p:spPr>
+          <a:xfrm>
+            <a:off x="3639312" y="2935224"/>
+            <a:ext cx="2066543" cy="594360"/>
+          </a:xfrm>
+          <a:prstGeom prst="rect">
+            <a:avLst/>
+          </a:prstGeom>
+          <a:noFill/>
+        </p:spPr>
+        <p:txBody>
+          <a:bodyPr wrap="square" lIns="9144" rIns="9144" tIns="9144" bIns="9144">
+            <a:spAutoFit/>
+          </a:bodyPr>
+          <a:lstStyle/>
+          <a:p>
+            <a:pPr>
+              <a:defRPr sz="1900" b="1">
                 <a:solidFill>
                   <a:srgbClr val="FFFFFF"/>
                 </a:solidFill>
@@ -7094,14 +7238,50 @@
       </p:sp>
       <p:sp>
         <p:nvSpPr>
-          <p:cNvPr id="16" name="Rounded Rectangle 15"/>
+          <p:cNvPr id="17" name="TextBox 16"/>
+          <p:cNvSpPr txBox="1"/>
+          <p:nvPr/>
+        </p:nvSpPr>
+        <p:spPr>
+          <a:xfrm>
+            <a:off x="3639312" y="3666744"/>
+            <a:ext cx="2057400" cy="713232"/>
+          </a:xfrm>
+          <a:prstGeom prst="rect">
+            <a:avLst/>
+          </a:prstGeom>
+          <a:noFill/>
+        </p:spPr>
+        <p:txBody>
+          <a:bodyPr wrap="square" lIns="9144" rIns="9144" tIns="9144" bIns="9144">
+            <a:spAutoFit/>
+          </a:bodyPr>
+          <a:lstStyle/>
+          <a:p>
+            <a:pPr>
+              <a:defRPr sz="1300" b="0">
+                <a:solidFill>
+                  <a:srgbClr val="C2ECDC"/>
+                </a:solidFill>
+                <a:latin typeface="Aptos"/>
+              </a:defRPr>
+            </a:pPr>
+            <a:r>
+              <a:t>Menyediakan sinyal dan prosedur pindah sel</a:t>
+            </a:r>
+          </a:p>
+        </p:txBody>
+      </p:sp>
+      <p:sp>
+        <p:nvSpPr>
+          <p:cNvPr id="18" name="Rounded Rectangle 17"/>
           <p:cNvSpPr/>
           <p:nvPr/>
         </p:nvSpPr>
         <p:spPr>
           <a:xfrm>
             <a:off x="6327648" y="2167128"/>
-            <a:ext cx="2395728" cy="2350008"/>
+            <a:ext cx="2395728" cy="2450592"/>
           </a:xfrm>
           <a:prstGeom prst="roundRect">
             <a:avLst>
@@ -7139,7 +7319,7 @@
       </p:sp>
       <p:sp>
         <p:nvSpPr>
-          <p:cNvPr id="17" name="Rectangle 16"/>
+          <p:cNvPr id="19" name="Rectangle 18"/>
           <p:cNvSpPr/>
           <p:nvPr/>
         </p:nvSpPr>
@@ -7182,13 +7362,13 @@
       </p:sp>
       <p:sp>
         <p:nvSpPr>
-          <p:cNvPr id="18" name="TextBox 17"/>
-          <p:cNvSpPr txBox="1"/>
-          <p:nvPr/>
-        </p:nvSpPr>
-        <p:spPr>
-          <a:xfrm>
-            <a:off x="6492240" y="2487168"/>
+          <p:cNvPr id="20" name="TextBox 19"/>
+          <p:cNvSpPr txBox="1"/>
+          <p:nvPr/>
+        </p:nvSpPr>
+        <p:spPr>
+          <a:xfrm>
+            <a:off x="6492240" y="2395728"/>
             <a:ext cx="2057400" cy="274320"/>
           </a:xfrm>
           <a:prstGeom prst="rect">
@@ -7218,28 +7398,28 @@
       </p:sp>
       <p:sp>
         <p:nvSpPr>
-          <p:cNvPr id="19" name="TextBox 18"/>
-          <p:cNvSpPr txBox="1"/>
-          <p:nvPr/>
-        </p:nvSpPr>
-        <p:spPr>
-          <a:xfrm>
-            <a:off x="6492240" y="3182112"/>
-            <a:ext cx="2066543" cy="758952"/>
-          </a:xfrm>
-          <a:prstGeom prst="rect">
-            <a:avLst/>
-          </a:prstGeom>
-          <a:noFill/>
-        </p:spPr>
-        <p:txBody>
-          <a:bodyPr wrap="square" lIns="9144" rIns="9144" tIns="9144" bIns="9144">
-            <a:spAutoFit/>
-          </a:bodyPr>
-          <a:lstStyle/>
-          <a:p>
-            <a:pPr>
-              <a:defRPr sz="2000" b="1">
+          <p:cNvPr id="21" name="TextBox 20"/>
+          <p:cNvSpPr txBox="1"/>
+          <p:nvPr/>
+        </p:nvSpPr>
+        <p:spPr>
+          <a:xfrm>
+            <a:off x="6492240" y="2935224"/>
+            <a:ext cx="2066543" cy="594360"/>
+          </a:xfrm>
+          <a:prstGeom prst="rect">
+            <a:avLst/>
+          </a:prstGeom>
+          <a:noFill/>
+        </p:spPr>
+        <p:txBody>
+          <a:bodyPr wrap="square" lIns="9144" rIns="9144" tIns="9144" bIns="9144">
+            <a:spAutoFit/>
+          </a:bodyPr>
+          <a:lstStyle/>
+          <a:p>
+            <a:pPr>
+              <a:defRPr sz="1900" b="1">
                 <a:solidFill>
                   <a:srgbClr val="FFFFFF"/>
                 </a:solidFill>
@@ -7254,14 +7434,50 @@
       </p:sp>
       <p:sp>
         <p:nvSpPr>
-          <p:cNvPr id="20" name="Rounded Rectangle 19"/>
+          <p:cNvPr id="22" name="TextBox 21"/>
+          <p:cNvSpPr txBox="1"/>
+          <p:nvPr/>
+        </p:nvSpPr>
+        <p:spPr>
+          <a:xfrm>
+            <a:off x="6492240" y="3666744"/>
+            <a:ext cx="2057400" cy="713232"/>
+          </a:xfrm>
+          <a:prstGeom prst="rect">
+            <a:avLst/>
+          </a:prstGeom>
+          <a:noFill/>
+        </p:spPr>
+        <p:txBody>
+          <a:bodyPr wrap="square" lIns="9144" rIns="9144" tIns="9144" bIns="9144">
+            <a:spAutoFit/>
+          </a:bodyPr>
+          <a:lstStyle/>
+          <a:p>
+            <a:pPr>
+              <a:defRPr sz="1300" b="0">
+                <a:solidFill>
+                  <a:srgbClr val="C2ECDC"/>
+                </a:solidFill>
+                <a:latin typeface="Aptos"/>
+              </a:defRPr>
+            </a:pPr>
+            <a:r>
+              <a:t>Ponsel bergerak sambil mengirim data</a:t>
+            </a:r>
+          </a:p>
+        </p:txBody>
+      </p:sp>
+      <p:sp>
+        <p:nvSpPr>
+          <p:cNvPr id="23" name="Rounded Rectangle 22"/>
           <p:cNvSpPr/>
           <p:nvPr/>
         </p:nvSpPr>
         <p:spPr>
           <a:xfrm>
             <a:off x="9180576" y="2167128"/>
-            <a:ext cx="2395728" cy="2350008"/>
+            <a:ext cx="2395728" cy="2450592"/>
           </a:xfrm>
           <a:prstGeom prst="roundRect">
             <a:avLst>
@@ -7299,7 +7515,7 @@
       </p:sp>
       <p:sp>
         <p:nvSpPr>
-          <p:cNvPr id="21" name="Rectangle 20"/>
+          <p:cNvPr id="24" name="Rectangle 23"/>
           <p:cNvSpPr/>
           <p:nvPr/>
         </p:nvSpPr>
@@ -7342,13 +7558,13 @@
       </p:sp>
       <p:sp>
         <p:nvSpPr>
-          <p:cNvPr id="22" name="TextBox 21"/>
-          <p:cNvSpPr txBox="1"/>
-          <p:nvPr/>
-        </p:nvSpPr>
-        <p:spPr>
-          <a:xfrm>
-            <a:off x="9345167" y="2487168"/>
+          <p:cNvPr id="25" name="TextBox 24"/>
+          <p:cNvSpPr txBox="1"/>
+          <p:nvPr/>
+        </p:nvSpPr>
+        <p:spPr>
+          <a:xfrm>
+            <a:off x="9345167" y="2395728"/>
             <a:ext cx="2057400" cy="274320"/>
           </a:xfrm>
           <a:prstGeom prst="rect">
@@ -7378,28 +7594,28 @@
       </p:sp>
       <p:sp>
         <p:nvSpPr>
-          <p:cNvPr id="23" name="TextBox 22"/>
-          <p:cNvSpPr txBox="1"/>
-          <p:nvPr/>
-        </p:nvSpPr>
-        <p:spPr>
-          <a:xfrm>
-            <a:off x="9345167" y="3182112"/>
-            <a:ext cx="2066543" cy="758952"/>
-          </a:xfrm>
-          <a:prstGeom prst="rect">
-            <a:avLst/>
-          </a:prstGeom>
-          <a:noFill/>
-        </p:spPr>
-        <p:txBody>
-          <a:bodyPr wrap="square" lIns="9144" rIns="9144" tIns="9144" bIns="9144">
-            <a:spAutoFit/>
-          </a:bodyPr>
-          <a:lstStyle/>
-          <a:p>
-            <a:pPr>
-              <a:defRPr sz="2000" b="1">
+          <p:cNvPr id="26" name="TextBox 25"/>
+          <p:cNvSpPr txBox="1"/>
+          <p:nvPr/>
+        </p:nvSpPr>
+        <p:spPr>
+          <a:xfrm>
+            <a:off x="9345167" y="2935224"/>
+            <a:ext cx="2066543" cy="594360"/>
+          </a:xfrm>
+          <a:prstGeom prst="rect">
+            <a:avLst/>
+          </a:prstGeom>
+          <a:noFill/>
+        </p:spPr>
+        <p:txBody>
+          <a:bodyPr wrap="square" lIns="9144" rIns="9144" tIns="9144" bIns="9144">
+            <a:spAutoFit/>
+          </a:bodyPr>
+          <a:lstStyle/>
+          <a:p>
+            <a:pPr>
+              <a:defRPr sz="1900" b="1">
                 <a:solidFill>
                   <a:srgbClr val="FFFFFF"/>
                 </a:solidFill>
@@ -7407,14 +7623,50 @@
               </a:defRPr>
             </a:pPr>
             <a:r>
-              <a:t>Agent + validator</a:t>
-            </a:r>
-          </a:p>
-        </p:txBody>
-      </p:sp>
-      <p:sp>
-        <p:nvSpPr>
-          <p:cNvPr id="24" name="TextBox 23"/>
+              <a:t>Agen + validator</a:t>
+            </a:r>
+          </a:p>
+        </p:txBody>
+      </p:sp>
+      <p:sp>
+        <p:nvSpPr>
+          <p:cNvPr id="27" name="TextBox 26"/>
+          <p:cNvSpPr txBox="1"/>
+          <p:nvPr/>
+        </p:nvSpPr>
+        <p:spPr>
+          <a:xfrm>
+            <a:off x="9345167" y="3666744"/>
+            <a:ext cx="2057400" cy="713232"/>
+          </a:xfrm>
+          <a:prstGeom prst="rect">
+            <a:avLst/>
+          </a:prstGeom>
+          <a:noFill/>
+        </p:spPr>
+        <p:txBody>
+          <a:bodyPr wrap="square" lIns="9144" rIns="9144" tIns="9144" bIns="9144">
+            <a:spAutoFit/>
+          </a:bodyPr>
+          <a:lstStyle/>
+          <a:p>
+            <a:pPr>
+              <a:defRPr sz="1300" b="0">
+                <a:solidFill>
+                  <a:srgbClr val="C2ECDC"/>
+                </a:solidFill>
+                <a:latin typeface="Aptos"/>
+              </a:defRPr>
+            </a:pPr>
+            <a:r>
+              <a:t>Mengusulkan lalu menyaring perubahan</a:t>
+            </a:r>
+          </a:p>
+        </p:txBody>
+      </p:sp>
+      <p:sp>
+        <p:nvSpPr>
+          <p:cNvPr id="28" name="TextBox 27"/>
           <p:cNvSpPr txBox="1"/>
           <p:nvPr/>
         </p:nvSpPr>
@@ -7443,14 +7695,14 @@
               </a:defRPr>
             </a:pPr>
             <a:r>
-              <a:t>↔</a:t>
-            </a:r>
-          </a:p>
-        </p:txBody>
-      </p:sp>
-      <p:sp>
-        <p:nvSpPr>
-          <p:cNvPr id="25" name="TextBox 24"/>
+              <a:t>→</a:t>
+            </a:r>
+          </a:p>
+        </p:txBody>
+      </p:sp>
+      <p:sp>
+        <p:nvSpPr>
+          <p:cNvPr id="29" name="TextBox 28"/>
           <p:cNvSpPr txBox="1"/>
           <p:nvPr/>
         </p:nvSpPr>
@@ -7479,14 +7731,14 @@
               </a:defRPr>
             </a:pPr>
             <a:r>
-              <a:t>↔</a:t>
-            </a:r>
-          </a:p>
-        </p:txBody>
-      </p:sp>
-      <p:sp>
-        <p:nvSpPr>
-          <p:cNvPr id="26" name="TextBox 25"/>
+              <a:t>→</a:t>
+            </a:r>
+          </a:p>
+        </p:txBody>
+      </p:sp>
+      <p:sp>
+        <p:nvSpPr>
+          <p:cNvPr id="30" name="TextBox 29"/>
           <p:cNvSpPr txBox="1"/>
           <p:nvPr/>
         </p:nvSpPr>
@@ -7515,14 +7767,14 @@
               </a:defRPr>
             </a:pPr>
             <a:r>
-              <a:t>↔</a:t>
-            </a:r>
-          </a:p>
-        </p:txBody>
-      </p:sp>
-      <p:sp>
-        <p:nvSpPr>
-          <p:cNvPr id="27" name="Rounded Rectangle 26"/>
+              <a:t>→</a:t>
+            </a:r>
+          </a:p>
+        </p:txBody>
+      </p:sp>
+      <p:sp>
+        <p:nvSpPr>
+          <p:cNvPr id="31" name="Rounded Rectangle 30"/>
           <p:cNvSpPr/>
           <p:nvPr/>
         </p:nvSpPr>
@@ -7567,7 +7819,7 @@
       </p:sp>
       <p:sp>
         <p:nvSpPr>
-          <p:cNvPr id="28" name="TextBox 27"/>
+          <p:cNvPr id="32" name="TextBox 31"/>
           <p:cNvSpPr txBox="1"/>
           <p:nvPr/>
         </p:nvSpPr>
@@ -7865,7 +8117,7 @@
         <p:spPr>
           <a:xfrm>
             <a:off x="658368" y="2002536"/>
-            <a:ext cx="5148072" cy="1444752"/>
+            <a:ext cx="5148072" cy="1527048"/>
           </a:xfrm>
           <a:prstGeom prst="roundRect">
             <a:avLst>
@@ -7981,8 +8233,8 @@
         </p:nvSpPr>
         <p:spPr>
           <a:xfrm>
-            <a:off x="1481328" y="2642615"/>
-            <a:ext cx="4041648" cy="594360"/>
+            <a:off x="1481328" y="2633472"/>
+            <a:ext cx="4041648" cy="768096"/>
           </a:xfrm>
           <a:prstGeom prst="rect">
             <a:avLst/>
@@ -8004,7 +8256,7 @@
               </a:defRPr>
             </a:pPr>
             <a:r>
-              <a:t>Dua sel dan UE target mampu berpindah dengan log yang jelas.</a:t>
+              <a:t>UE harus bisa pindah sel berkali-kali; setiap keberhasilan dan kegagalan tercatat.</a:t>
             </a:r>
           </a:p>
         </p:txBody>
@@ -8018,7 +8270,7 @@
         <p:spPr>
           <a:xfrm>
             <a:off x="6208776" y="2002536"/>
-            <a:ext cx="5148072" cy="1444752"/>
+            <a:ext cx="5148072" cy="1527048"/>
           </a:xfrm>
           <a:prstGeom prst="roundRect">
             <a:avLst>
@@ -8134,8 +8386,8 @@
         </p:nvSpPr>
         <p:spPr>
           <a:xfrm>
-            <a:off x="7031736" y="2642615"/>
-            <a:ext cx="4041648" cy="594360"/>
+            <a:off x="7031736" y="2633472"/>
+            <a:ext cx="4041648" cy="768096"/>
           </a:xfrm>
           <a:prstGeom prst="rect">
             <a:avLst/>
@@ -8157,7 +8409,7 @@
               </a:defRPr>
             </a:pPr>
             <a:r>
-              <a:t>Definisi ping-pong, RLF, dan waktu trafik konsisten.</a:t>
+              <a:t>RLF = radio link failure (sambungan radio gagal). Log sinyal dan trafik harus selaras waktu.</a:t>
             </a:r>
           </a:p>
         </p:txBody>
@@ -8171,7 +8423,7 @@
         <p:spPr>
           <a:xfrm>
             <a:off x="658368" y="3685032"/>
-            <a:ext cx="5148072" cy="1444752"/>
+            <a:ext cx="5148072" cy="1527048"/>
           </a:xfrm>
           <a:prstGeom prst="roundRect">
             <a:avLst>
@@ -8287,8 +8539,8 @@
         </p:nvSpPr>
         <p:spPr>
           <a:xfrm>
-            <a:off x="1481328" y="4325112"/>
-            <a:ext cx="4041648" cy="594360"/>
+            <a:off x="1481328" y="4315968"/>
+            <a:ext cx="4041648" cy="768096"/>
           </a:xfrm>
           <a:prstGeom prst="rect">
             <a:avLst/>
@@ -8310,7 +8562,7 @@
               </a:defRPr>
             </a:pPr>
             <a:r>
-              <a:t>Ruang pilihan, validator, fallback, dan rollback bekerja.</a:t>
+              <a:t>Validator membatasi nilai. Fallback memakai setelan awal; rollback mengembalikan setelan sebelumnya.</a:t>
             </a:r>
           </a:p>
         </p:txBody>
@@ -8324,7 +8576,7 @@
         <p:spPr>
           <a:xfrm>
             <a:off x="6208776" y="3685032"/>
-            <a:ext cx="5148072" cy="1444752"/>
+            <a:ext cx="5148072" cy="1527048"/>
           </a:xfrm>
           <a:prstGeom prst="roundRect">
             <a:avLst>
@@ -8440,8 +8692,8 @@
         </p:nvSpPr>
         <p:spPr>
           <a:xfrm>
-            <a:off x="7031736" y="4325112"/>
-            <a:ext cx="4041648" cy="594360"/>
+            <a:off x="7031736" y="4315968"/>
+            <a:ext cx="4041648" cy="768096"/>
           </a:xfrm>
           <a:prstGeom prst="rect">
             <a:avLst/>
@@ -8463,7 +8715,7 @@
               </a:defRPr>
             </a:pPr>
             <a:r>
-              <a:t>Perbandingan dilakukan pada skenario yang sama dan berulang.</a:t>
+              <a:t>Lintasan, UE, trafik, dan durasi uji dibuat sama agar perubahan kinerja dapat dibandingkan.</a:t>
             </a:r>
           </a:p>
         </p:txBody>
@@ -8732,7 +8984,7 @@
         <p:spPr>
           <a:xfrm>
             <a:off x="658368" y="1965960"/>
-            <a:ext cx="5138928" cy="1472184"/>
+            <a:ext cx="5138928" cy="1572768"/>
           </a:xfrm>
           <a:prstGeom prst="roundRect">
             <a:avLst>
@@ -8777,7 +9029,7 @@
         <p:spPr>
           <a:xfrm>
             <a:off x="658368" y="1965960"/>
-            <a:ext cx="109728" cy="1472184"/>
+            <a:ext cx="109728" cy="1572768"/>
           </a:xfrm>
           <a:prstGeom prst="rect">
             <a:avLst/>
@@ -8819,7 +9071,7 @@
         </p:nvSpPr>
         <p:spPr>
           <a:xfrm>
-            <a:off x="941832" y="2185415"/>
+            <a:off x="941832" y="2148840"/>
             <a:ext cx="4480560" cy="365760"/>
           </a:xfrm>
           <a:prstGeom prst="rect">
@@ -8855,22 +9107,22 @@
         </p:nvSpPr>
         <p:spPr>
           <a:xfrm>
-            <a:off x="941832" y="2724912"/>
-            <a:ext cx="4507992" cy="521207"/>
-          </a:xfrm>
-          <a:prstGeom prst="rect">
-            <a:avLst/>
-          </a:prstGeom>
-          <a:noFill/>
-        </p:spPr>
-        <p:txBody>
-          <a:bodyPr wrap="square" lIns="9144" rIns="9144" tIns="9144" bIns="9144">
-            <a:spAutoFit/>
-          </a:bodyPr>
-          <a:lstStyle/>
-          <a:p>
-            <a:pPr>
-              <a:defRPr sz="1500" b="0">
+            <a:off x="941832" y="2624328"/>
+            <a:ext cx="4507992" cy="795528"/>
+          </a:xfrm>
+          <a:prstGeom prst="rect">
+            <a:avLst/>
+          </a:prstGeom>
+          <a:noFill/>
+        </p:spPr>
+        <p:txBody>
+          <a:bodyPr wrap="square" lIns="9144" rIns="9144" tIns="9144" bIns="9144">
+            <a:spAutoFit/>
+          </a:bodyPr>
+          <a:lstStyle/>
+          <a:p>
+            <a:pPr>
+              <a:defRPr sz="1400" b="0">
                 <a:solidFill>
                   <a:srgbClr val="5C6B6F"/>
                 </a:solidFill>
@@ -8878,7 +9130,7 @@
               </a:defRPr>
             </a:pPr>
             <a:r>
-              <a:t>Batasi frekuensi panggilan dan catat biaya.</a:t>
+              <a:t>Model berbasis API dikenai biaya per pemakaian; interval analisis perlu dibatasi dan dicatat.</a:t>
             </a:r>
           </a:p>
         </p:txBody>
@@ -8892,7 +9144,7 @@
         <p:spPr>
           <a:xfrm>
             <a:off x="6199631" y="1965960"/>
-            <a:ext cx="5138928" cy="1472184"/>
+            <a:ext cx="5138928" cy="1572768"/>
           </a:xfrm>
           <a:prstGeom prst="roundRect">
             <a:avLst>
@@ -8937,7 +9189,7 @@
         <p:spPr>
           <a:xfrm>
             <a:off x="6199631" y="1965960"/>
-            <a:ext cx="109728" cy="1472184"/>
+            <a:ext cx="109728" cy="1572768"/>
           </a:xfrm>
           <a:prstGeom prst="rect">
             <a:avLst/>
@@ -8979,7 +9231,7 @@
         </p:nvSpPr>
         <p:spPr>
           <a:xfrm>
-            <a:off x="6483095" y="2185415"/>
+            <a:off x="6483095" y="2148840"/>
             <a:ext cx="4480560" cy="365760"/>
           </a:xfrm>
           <a:prstGeom prst="rect">
@@ -9015,22 +9267,22 @@
         </p:nvSpPr>
         <p:spPr>
           <a:xfrm>
-            <a:off x="6483095" y="2724912"/>
-            <a:ext cx="4507992" cy="521207"/>
-          </a:xfrm>
-          <a:prstGeom prst="rect">
-            <a:avLst/>
-          </a:prstGeom>
-          <a:noFill/>
-        </p:spPr>
-        <p:txBody>
-          <a:bodyPr wrap="square" lIns="9144" rIns="9144" tIns="9144" bIns="9144">
-            <a:spAutoFit/>
-          </a:bodyPr>
-          <a:lstStyle/>
-          <a:p>
-            <a:pPr>
-              <a:defRPr sz="1500" b="0">
+            <a:off x="6483095" y="2624328"/>
+            <a:ext cx="4507992" cy="795528"/>
+          </a:xfrm>
+          <a:prstGeom prst="rect">
+            <a:avLst/>
+          </a:prstGeom>
+          <a:noFill/>
+        </p:spPr>
+        <p:txBody>
+          <a:bodyPr wrap="square" lIns="9144" rIns="9144" tIns="9144" bIns="9144">
+            <a:spAutoFit/>
+          </a:bodyPr>
+          <a:lstStyle/>
+          <a:p>
+            <a:pPr>
+              <a:defRPr sz="1400" b="0">
                 <a:solidFill>
                   <a:srgbClr val="5C6B6F"/>
                 </a:solidFill>
@@ -9038,7 +9290,7 @@
               </a:defRPr>
             </a:pPr>
             <a:r>
-              <a:t>Kirim telemetri minimum yang diperlukan.</a:t>
+              <a:t>Kirim hanya ringkasan kondisi radio; identitas UE dan kunci API dijaga di sistem lokal.</a:t>
             </a:r>
           </a:p>
         </p:txBody>
@@ -9052,7 +9304,7 @@
         <p:spPr>
           <a:xfrm>
             <a:off x="658368" y="3685031"/>
-            <a:ext cx="5138928" cy="1472184"/>
+            <a:ext cx="5138928" cy="1572768"/>
           </a:xfrm>
           <a:prstGeom prst="roundRect">
             <a:avLst>
@@ -9097,7 +9349,7 @@
         <p:spPr>
           <a:xfrm>
             <a:off x="658368" y="3685031"/>
-            <a:ext cx="109728" cy="1472184"/>
+            <a:ext cx="109728" cy="1572768"/>
           </a:xfrm>
           <a:prstGeom prst="rect">
             <a:avLst/>
@@ -9139,7 +9391,7 @@
         </p:nvSpPr>
         <p:spPr>
           <a:xfrm>
-            <a:off x="941832" y="3904487"/>
+            <a:off x="941832" y="3867911"/>
             <a:ext cx="4480560" cy="365760"/>
           </a:xfrm>
           <a:prstGeom prst="rect">
@@ -9175,22 +9427,22 @@
         </p:nvSpPr>
         <p:spPr>
           <a:xfrm>
-            <a:off x="941832" y="4443983"/>
-            <a:ext cx="4507992" cy="521207"/>
-          </a:xfrm>
-          <a:prstGeom prst="rect">
-            <a:avLst/>
-          </a:prstGeom>
-          <a:noFill/>
-        </p:spPr>
-        <p:txBody>
-          <a:bodyPr wrap="square" lIns="9144" rIns="9144" tIns="9144" bIns="9144">
-            <a:spAutoFit/>
-          </a:bodyPr>
-          <a:lstStyle/>
-          <a:p>
-            <a:pPr>
-              <a:defRPr sz="1500" b="0">
+            <a:off x="941832" y="4343399"/>
+            <a:ext cx="4507992" cy="795528"/>
+          </a:xfrm>
+          <a:prstGeom prst="rect">
+            <a:avLst/>
+          </a:prstGeom>
+          <a:noFill/>
+        </p:spPr>
+        <p:txBody>
+          <a:bodyPr wrap="square" lIns="9144" rIns="9144" tIns="9144" bIns="9144">
+            <a:spAutoFit/>
+          </a:bodyPr>
+          <a:lstStyle/>
+          <a:p>
+            <a:pPr>
+              <a:defRPr sz="1400" b="0">
                 <a:solidFill>
                   <a:srgbClr val="5C6B6F"/>
                 </a:solidFill>
@@ -9198,7 +9450,7 @@
               </a:defRPr>
             </a:pPr>
             <a:r>
-              <a:t>Gunakan konfigurasi baseline saat layanan gagal.</a:t>
+              <a:t>Jika jaringan/API gagal atau lambat, RAN tetap berjalan memakai konfigurasi baseline.</a:t>
             </a:r>
           </a:p>
         </p:txBody>
@@ -9212,7 +9464,7 @@
         <p:spPr>
           <a:xfrm>
             <a:off x="6199631" y="3685031"/>
-            <a:ext cx="5138928" cy="1472184"/>
+            <a:ext cx="5138928" cy="1572768"/>
           </a:xfrm>
           <a:prstGeom prst="roundRect">
             <a:avLst>
@@ -9257,7 +9509,7 @@
         <p:spPr>
           <a:xfrm>
             <a:off x="6199631" y="3685031"/>
-            <a:ext cx="109728" cy="1472184"/>
+            <a:ext cx="109728" cy="1572768"/>
           </a:xfrm>
           <a:prstGeom prst="rect">
             <a:avLst/>
@@ -9299,7 +9551,7 @@
         </p:nvSpPr>
         <p:spPr>
           <a:xfrm>
-            <a:off x="6483095" y="3904487"/>
+            <a:off x="6483095" y="3867911"/>
             <a:ext cx="4480560" cy="365760"/>
           </a:xfrm>
           <a:prstGeom prst="rect">
@@ -9335,22 +9587,22 @@
         </p:nvSpPr>
         <p:spPr>
           <a:xfrm>
-            <a:off x="6483095" y="4443983"/>
-            <a:ext cx="4507992" cy="521207"/>
-          </a:xfrm>
-          <a:prstGeom prst="rect">
-            <a:avLst/>
-          </a:prstGeom>
-          <a:noFill/>
-        </p:spPr>
-        <p:txBody>
-          <a:bodyPr wrap="square" lIns="9144" rIns="9144" tIns="9144" bIns="9144">
-            <a:spAutoFit/>
-          </a:bodyPr>
-          <a:lstStyle/>
-          <a:p>
-            <a:pPr>
-              <a:defRPr sz="1500" b="0">
+            <a:off x="6483095" y="4343399"/>
+            <a:ext cx="4507992" cy="795528"/>
+          </a:xfrm>
+          <a:prstGeom prst="rect">
+            <a:avLst/>
+          </a:prstGeom>
+          <a:noFill/>
+        </p:spPr>
+        <p:txBody>
+          <a:bodyPr wrap="square" lIns="9144" rIns="9144" tIns="9144" bIns="9144">
+            <a:spAutoFit/>
+          </a:bodyPr>
+          <a:lstStyle/>
+          <a:p>
+            <a:pPr>
+              <a:defRPr sz="1400" b="0">
                 <a:solidFill>
                   <a:srgbClr val="5C6B6F"/>
                 </a:solidFill>
@@ -9358,7 +9610,7 @@
               </a:defRPr>
             </a:pPr>
             <a:r>
-              <a:t>Jadwalkan perangkat, lintasan, dan UE secara konsisten.</a:t>
+              <a:t>Perangkat SDR, UE, dan waktu pengujian terbatas; jadwal dan prosedur uji perlu konsisten.</a:t>
             </a:r>
           </a:p>
         </p:txBody>
@@ -9801,22 +10053,22 @@
         </p:nvSpPr>
         <p:spPr>
           <a:xfrm>
-            <a:off x="914400" y="4471416"/>
-            <a:ext cx="4480560" cy="310896"/>
-          </a:xfrm>
-          <a:prstGeom prst="rect">
-            <a:avLst/>
-          </a:prstGeom>
-          <a:noFill/>
-        </p:spPr>
-        <p:txBody>
-          <a:bodyPr wrap="square" lIns="9144" rIns="9144" tIns="9144" bIns="9144">
-            <a:spAutoFit/>
-          </a:bodyPr>
-          <a:lstStyle/>
-          <a:p>
-            <a:pPr>
-              <a:defRPr sz="1500" b="0">
+            <a:off x="914400" y="4270248"/>
+            <a:ext cx="4498848" cy="621792"/>
+          </a:xfrm>
+          <a:prstGeom prst="rect">
+            <a:avLst/>
+          </a:prstGeom>
+          <a:noFill/>
+        </p:spPr>
+        <p:txBody>
+          <a:bodyPr wrap="square" lIns="9144" rIns="9144" tIns="9144" bIns="9144">
+            <a:spAutoFit/>
+          </a:bodyPr>
+          <a:lstStyle/>
+          <a:p>
+            <a:pPr>
+              <a:defRPr sz="1400" b="0">
                 <a:solidFill>
                   <a:srgbClr val="C2ECDC"/>
                 </a:solidFill>
@@ -9824,7 +10076,7 @@
               </a:defRPr>
             </a:pPr>
             <a:r>
-              <a:t>Skenario, UE, dan trafik dibuat sama.</a:t>
+              <a:t>Baseline = parameter A3 tetap. Agen = usulan adaptasi setelah membaca kondisi jaringan.</a:t>
             </a:r>
           </a:p>
         </p:txBody>
@@ -9909,22 +10161,22 @@
         </p:nvSpPr>
         <p:spPr>
           <a:xfrm>
-            <a:off x="6473952" y="3227832"/>
-            <a:ext cx="4553712" cy="704088"/>
-          </a:xfrm>
-          <a:prstGeom prst="rect">
-            <a:avLst/>
-          </a:prstGeom>
-          <a:noFill/>
-        </p:spPr>
-        <p:txBody>
-          <a:bodyPr wrap="square" lIns="9144" rIns="9144" tIns="9144" bIns="9144">
-            <a:spAutoFit/>
-          </a:bodyPr>
-          <a:lstStyle/>
-          <a:p>
-            <a:pPr>
-              <a:defRPr sz="1500" b="0">
+            <a:off x="6473952" y="3182112"/>
+            <a:ext cx="4553712" cy="877824"/>
+          </a:xfrm>
+          <a:prstGeom prst="rect">
+            <a:avLst/>
+          </a:prstGeom>
+          <a:noFill/>
+        </p:spPr>
+        <p:txBody>
+          <a:bodyPr wrap="square" lIns="9144" rIns="9144" tIns="9144" bIns="9144">
+            <a:spAutoFit/>
+          </a:bodyPr>
+          <a:lstStyle/>
+          <a:p>
+            <a:pPr>
+              <a:defRPr sz="1300" b="0">
                 <a:solidFill>
                   <a:srgbClr val="C2ECDC"/>
                 </a:solidFill>
@@ -9932,20 +10184,7 @@
               </a:defRPr>
             </a:pPr>
             <a:r>
-              <a:t>HO sukses/gagal  •  ping-pong  •  RLF</a:t>
-            </a:r>
-          </a:p>
-          <a:p>
-            <a:pPr>
-              <a:defRPr sz="1500" b="0">
-                <a:solidFill>
-                  <a:srgbClr val="C2ECDC"/>
-                </a:solidFill>
-                <a:latin typeface="Aptos"/>
-              </a:defRPr>
-            </a:pPr>
-            <a:r>
-              <a:t>throughput  •  pemulihan trafik</a:t>
+              <a:t>HO = handover; ping-pong = kembali ke sel asal; RLF = sambungan radio gagal. Ukur juga throughput dan waktu trafik pulih.</a:t>
             </a:r>
           </a:p>
         </p:txBody>
@@ -9994,22 +10233,22 @@
         </p:nvSpPr>
         <p:spPr>
           <a:xfrm>
-            <a:off x="6473952" y="4535424"/>
-            <a:ext cx="4590288" cy="484632"/>
-          </a:xfrm>
-          <a:prstGeom prst="rect">
-            <a:avLst/>
-          </a:prstGeom>
-          <a:noFill/>
-        </p:spPr>
-        <p:txBody>
-          <a:bodyPr wrap="square" lIns="9144" rIns="9144" tIns="9144" bIns="9144">
-            <a:spAutoFit/>
-          </a:bodyPr>
-          <a:lstStyle/>
-          <a:p>
-            <a:pPr>
-              <a:defRPr sz="1500" b="0">
+            <a:off x="6473952" y="4462272"/>
+            <a:ext cx="4590288" cy="630936"/>
+          </a:xfrm>
+          <a:prstGeom prst="rect">
+            <a:avLst/>
+          </a:prstGeom>
+          <a:noFill/>
+        </p:spPr>
+        <p:txBody>
+          <a:bodyPr wrap="square" lIns="9144" rIns="9144" tIns="9144" bIns="9144">
+            <a:spAutoFit/>
+          </a:bodyPr>
+          <a:lstStyle/>
+          <a:p>
+            <a:pPr>
+              <a:defRPr sz="1300" b="0">
                 <a:solidFill>
                   <a:srgbClr val="C2ECDC"/>
                 </a:solidFill>
@@ -10017,7 +10256,7 @@
               </a:defRPr>
             </a:pPr>
             <a:r>
-              <a:t>validitas usulan  •  latensi  •  biaya  •  rollback</a:t>
+              <a:t>Apakah usulan lolos validator? Berapa lama respons API, biayanya, dan apakah rollback berhasil?</a:t>
             </a:r>
           </a:p>
         </p:txBody>

</xml_diff>